<commit_message>
v2.32: menú Cajas (físicas) Galicia-f y Morba-s/f (ARS).
Co-authored-by: Cursor <cursoragent@cursor.com>
</commit_message>
<xml_diff>
--- a/Propuesta_Dashboard_Flujo_Caja.pptx
+++ b/Propuesta_Dashboard_Flujo_Caja.pptx
@@ -6759,7 +6759,7 @@
                           <a:ea typeface="Calibri" pitchFamily="34" charset="-122"/>
                           <a:cs typeface="Calibri" pitchFamily="34" charset="-120"/>
                         </a:rPr>
-                        <a:t>Total</a:t>
+                        <a:t>Cajas (físicas)</a:t>
                       </a:r>
                       <a:endParaRPr lang="en-US" sz="1000" dirty="0">
                         <a:latin typeface="Calibri" charset="0"/>
@@ -6824,7 +6824,204 @@
                           <a:ea typeface="Calibri" pitchFamily="34" charset="-122"/>
                           <a:cs typeface="Calibri" pitchFamily="34" charset="-120"/>
                         </a:rPr>
-                        <a:t>149</a:t>
+                        <a:t>8</a:t>
+                      </a:r>
+                      <a:endParaRPr lang="en-US" sz="1000" dirty="0">
+                        <a:latin typeface="Calibri" charset="0"/>
+                        <a:ea typeface="Calibri" charset="0"/>
+                        <a:cs typeface="Calibri" charset="0"/>
+                      </a:endParaRPr>
+                    </a:p>
+                  </a:txBody>
+                  <a:tcPr marL="50800" marR="50800" marT="50800" marB="50800" anchor="ctr">
+                    <a:lnL w="6350" cap="flat" cmpd="sng" algn="ctr">
+                      <a:solidFill>
+                        <a:srgbClr val="CCCCCC"/>
+                      </a:solidFill>
+                      <a:prstDash val="solid"/>
+                      <a:round/>
+                      <a:headEnd type="none" w="med" len="med"/>
+                      <a:tailEnd type="none" w="med" len="med"/>
+                    </a:lnL>
+                    <a:lnR w="6350" cap="flat" cmpd="sng" algn="ctr">
+                      <a:solidFill>
+                        <a:srgbClr val="CCCCCC"/>
+                      </a:solidFill>
+                      <a:prstDash val="solid"/>
+                      <a:round/>
+                      <a:headEnd type="none" w="med" len="med"/>
+                      <a:tailEnd type="none" w="med" len="med"/>
+                    </a:lnR>
+                    <a:lnT w="6350" cap="flat" cmpd="sng" algn="ctr">
+                      <a:solidFill>
+                        <a:srgbClr val="CCCCCC"/>
+                      </a:solidFill>
+                      <a:prstDash val="solid"/>
+                      <a:round/>
+                      <a:headEnd type="none" w="med" len="med"/>
+                      <a:tailEnd type="none" w="med" len="med"/>
+                    </a:lnT>
+                    <a:lnB w="6350" cap="flat" cmpd="sng" algn="ctr">
+                      <a:solidFill>
+                        <a:srgbClr val="CCCCCC"/>
+                      </a:solidFill>
+                      <a:prstDash val="solid"/>
+                      <a:round/>
+                      <a:headEnd type="none" w="med" len="med"/>
+                      <a:tailEnd type="none" w="med" len="med"/>
+                    </a:lnB>
+                  </a:tcPr>
+                </a:tc>
+                <a:tc>
+                  <a:txBody>
+                    <a:bodyPr/>
+                    <a:lstStyle/>
+                    <a:p>
+                      <a:pPr algn="l" indent="0" marL="0">
+                        <a:buNone/>
+                      </a:pPr>
+                      <a:r>
+                        <a:rPr lang="en-US" sz="1000" dirty="0">
+                          <a:solidFill>
+                            <a:srgbClr val="000000"/>
+                          </a:solidFill>
+                          <a:latin typeface="Calibri" pitchFamily="34" charset="0"/>
+                          <a:ea typeface="Calibri" pitchFamily="34" charset="-122"/>
+                          <a:cs typeface="Calibri" pitchFamily="34" charset="-120"/>
+                        </a:rPr>
+                        <a:t>0</a:t>
+                      </a:r>
+                      <a:endParaRPr lang="en-US" sz="1000" dirty="0">
+                        <a:latin typeface="Calibri" charset="0"/>
+                        <a:ea typeface="Calibri" charset="0"/>
+                        <a:cs typeface="Calibri" charset="0"/>
+                      </a:endParaRPr>
+                    </a:p>
+                  </a:txBody>
+                  <a:tcPr marL="50800" marR="50800" marT="50800" marB="50800" anchor="ctr">
+                    <a:lnL w="6350" cap="flat" cmpd="sng" algn="ctr">
+                      <a:solidFill>
+                        <a:srgbClr val="CCCCCC"/>
+                      </a:solidFill>
+                      <a:prstDash val="solid"/>
+                      <a:round/>
+                      <a:headEnd type="none" w="med" len="med"/>
+                      <a:tailEnd type="none" w="med" len="med"/>
+                    </a:lnL>
+                    <a:lnR w="6350" cap="flat" cmpd="sng" algn="ctr">
+                      <a:solidFill>
+                        <a:srgbClr val="CCCCCC"/>
+                      </a:solidFill>
+                      <a:prstDash val="solid"/>
+                      <a:round/>
+                      <a:headEnd type="none" w="med" len="med"/>
+                      <a:tailEnd type="none" w="med" len="med"/>
+                    </a:lnR>
+                    <a:lnT w="6350" cap="flat" cmpd="sng" algn="ctr">
+                      <a:solidFill>
+                        <a:srgbClr val="CCCCCC"/>
+                      </a:solidFill>
+                      <a:prstDash val="solid"/>
+                      <a:round/>
+                      <a:headEnd type="none" w="med" len="med"/>
+                      <a:tailEnd type="none" w="med" len="med"/>
+                    </a:lnT>
+                    <a:lnB w="6350" cap="flat" cmpd="sng" algn="ctr">
+                      <a:solidFill>
+                        <a:srgbClr val="CCCCCC"/>
+                      </a:solidFill>
+                      <a:prstDash val="solid"/>
+                      <a:round/>
+                      <a:headEnd type="none" w="med" len="med"/>
+                      <a:tailEnd type="none" w="med" len="med"/>
+                    </a:lnB>
+                  </a:tcPr>
+                </a:tc>
+              </a:tr>
+              <a:tr h="0">
+                <a:tc>
+                  <a:txBody>
+                    <a:bodyPr/>
+                    <a:lstStyle/>
+                    <a:p>
+                      <a:pPr algn="l" indent="0" marL="0">
+                        <a:buNone/>
+                      </a:pPr>
+                      <a:r>
+                        <a:rPr lang="en-US" sz="1000" dirty="0">
+                          <a:solidFill>
+                            <a:srgbClr val="000000"/>
+                          </a:solidFill>
+                          <a:latin typeface="Calibri" pitchFamily="34" charset="0"/>
+                          <a:ea typeface="Calibri" pitchFamily="34" charset="-122"/>
+                          <a:cs typeface="Calibri" pitchFamily="34" charset="-120"/>
+                        </a:rPr>
+                        <a:t>Total</a:t>
+                      </a:r>
+                      <a:endParaRPr lang="en-US" sz="1000" dirty="0">
+                        <a:latin typeface="Calibri" charset="0"/>
+                        <a:ea typeface="Calibri" charset="0"/>
+                        <a:cs typeface="Calibri" charset="0"/>
+                      </a:endParaRPr>
+                    </a:p>
+                  </a:txBody>
+                  <a:tcPr marL="50800" marR="50800" marT="50800" marB="50800" anchor="ctr">
+                    <a:lnL w="6350" cap="flat" cmpd="sng" algn="ctr">
+                      <a:solidFill>
+                        <a:srgbClr val="CCCCCC"/>
+                      </a:solidFill>
+                      <a:prstDash val="solid"/>
+                      <a:round/>
+                      <a:headEnd type="none" w="med" len="med"/>
+                      <a:tailEnd type="none" w="med" len="med"/>
+                    </a:lnL>
+                    <a:lnR w="6350" cap="flat" cmpd="sng" algn="ctr">
+                      <a:solidFill>
+                        <a:srgbClr val="CCCCCC"/>
+                      </a:solidFill>
+                      <a:prstDash val="solid"/>
+                      <a:round/>
+                      <a:headEnd type="none" w="med" len="med"/>
+                      <a:tailEnd type="none" w="med" len="med"/>
+                    </a:lnR>
+                    <a:lnT w="6350" cap="flat" cmpd="sng" algn="ctr">
+                      <a:solidFill>
+                        <a:srgbClr val="CCCCCC"/>
+                      </a:solidFill>
+                      <a:prstDash val="solid"/>
+                      <a:round/>
+                      <a:headEnd type="none" w="med" len="med"/>
+                      <a:tailEnd type="none" w="med" len="med"/>
+                    </a:lnT>
+                    <a:lnB w="6350" cap="flat" cmpd="sng" algn="ctr">
+                      <a:solidFill>
+                        <a:srgbClr val="CCCCCC"/>
+                      </a:solidFill>
+                      <a:prstDash val="solid"/>
+                      <a:round/>
+                      <a:headEnd type="none" w="med" len="med"/>
+                      <a:tailEnd type="none" w="med" len="med"/>
+                    </a:lnB>
+                  </a:tcPr>
+                </a:tc>
+                <a:tc>
+                  <a:txBody>
+                    <a:bodyPr/>
+                    <a:lstStyle/>
+                    <a:p>
+                      <a:pPr algn="l" indent="0" marL="0">
+                        <a:buNone/>
+                      </a:pPr>
+                      <a:r>
+                        <a:rPr lang="en-US" sz="1000" dirty="0">
+                          <a:solidFill>
+                            <a:srgbClr val="000000"/>
+                          </a:solidFill>
+                          <a:latin typeface="Calibri" pitchFamily="34" charset="0"/>
+                          <a:ea typeface="Calibri" pitchFamily="34" charset="-122"/>
+                          <a:cs typeface="Calibri" pitchFamily="34" charset="-120"/>
+                        </a:rPr>
+                        <a:t>157</a:t>
                       </a:r>
                       <a:endParaRPr lang="en-US" sz="1000" dirty="0">
                         <a:latin typeface="Calibri" charset="0"/>
@@ -6975,7 +7172,7 @@
                 <a:ea typeface="Calibri" pitchFamily="34" charset="-122"/>
                 <a:cs typeface="Calibri" pitchFamily="34" charset="-120"/>
               </a:rPr>
-              <a:t>Total: 149 horas hombre · 5,500 USD</a:t>
+              <a:t>Total: 157 horas hombre · 5,500 USD</a:t>
             </a:r>
             <a:endParaRPr lang="en-US" sz="1200" dirty="0"/>
           </a:p>

</xml_diff>

<commit_message>
v2.36: Impuestos MP, extracto Galicia PDF y confirmar todos en Sugeridos.
Co-authored-by: Cursor <cursoragent@cursor.com>
</commit_message>
<xml_diff>
--- a/Propuesta_Dashboard_Flujo_Caja.pptx
+++ b/Propuesta_Dashboard_Flujo_Caja.pptx
@@ -6956,7 +6956,7 @@
                           <a:ea typeface="Calibri" pitchFamily="34" charset="-122"/>
                           <a:cs typeface="Calibri" pitchFamily="34" charset="-120"/>
                         </a:rPr>
-                        <a:t>Total</a:t>
+                        <a:t>Impuestos</a:t>
                       </a:r>
                       <a:endParaRPr lang="en-US" sz="1000" dirty="0">
                         <a:latin typeface="Calibri" charset="0"/>
@@ -7021,7 +7021,204 @@
                           <a:ea typeface="Calibri" pitchFamily="34" charset="-122"/>
                           <a:cs typeface="Calibri" pitchFamily="34" charset="-120"/>
                         </a:rPr>
-                        <a:t>157</a:t>
+                        <a:t>8</a:t>
+                      </a:r>
+                      <a:endParaRPr lang="en-US" sz="1000" dirty="0">
+                        <a:latin typeface="Calibri" charset="0"/>
+                        <a:ea typeface="Calibri" charset="0"/>
+                        <a:cs typeface="Calibri" charset="0"/>
+                      </a:endParaRPr>
+                    </a:p>
+                  </a:txBody>
+                  <a:tcPr marL="50800" marR="50800" marT="50800" marB="50800" anchor="ctr">
+                    <a:lnL w="6350" cap="flat" cmpd="sng" algn="ctr">
+                      <a:solidFill>
+                        <a:srgbClr val="CCCCCC"/>
+                      </a:solidFill>
+                      <a:prstDash val="solid"/>
+                      <a:round/>
+                      <a:headEnd type="none" w="med" len="med"/>
+                      <a:tailEnd type="none" w="med" len="med"/>
+                    </a:lnL>
+                    <a:lnR w="6350" cap="flat" cmpd="sng" algn="ctr">
+                      <a:solidFill>
+                        <a:srgbClr val="CCCCCC"/>
+                      </a:solidFill>
+                      <a:prstDash val="solid"/>
+                      <a:round/>
+                      <a:headEnd type="none" w="med" len="med"/>
+                      <a:tailEnd type="none" w="med" len="med"/>
+                    </a:lnR>
+                    <a:lnT w="6350" cap="flat" cmpd="sng" algn="ctr">
+                      <a:solidFill>
+                        <a:srgbClr val="CCCCCC"/>
+                      </a:solidFill>
+                      <a:prstDash val="solid"/>
+                      <a:round/>
+                      <a:headEnd type="none" w="med" len="med"/>
+                      <a:tailEnd type="none" w="med" len="med"/>
+                    </a:lnT>
+                    <a:lnB w="6350" cap="flat" cmpd="sng" algn="ctr">
+                      <a:solidFill>
+                        <a:srgbClr val="CCCCCC"/>
+                      </a:solidFill>
+                      <a:prstDash val="solid"/>
+                      <a:round/>
+                      <a:headEnd type="none" w="med" len="med"/>
+                      <a:tailEnd type="none" w="med" len="med"/>
+                    </a:lnB>
+                  </a:tcPr>
+                </a:tc>
+                <a:tc>
+                  <a:txBody>
+                    <a:bodyPr/>
+                    <a:lstStyle/>
+                    <a:p>
+                      <a:pPr algn="l" indent="0" marL="0">
+                        <a:buNone/>
+                      </a:pPr>
+                      <a:r>
+                        <a:rPr lang="en-US" sz="1000" dirty="0">
+                          <a:solidFill>
+                            <a:srgbClr val="000000"/>
+                          </a:solidFill>
+                          <a:latin typeface="Calibri" pitchFamily="34" charset="0"/>
+                          <a:ea typeface="Calibri" pitchFamily="34" charset="-122"/>
+                          <a:cs typeface="Calibri" pitchFamily="34" charset="-120"/>
+                        </a:rPr>
+                        <a:t>0</a:t>
+                      </a:r>
+                      <a:endParaRPr lang="en-US" sz="1000" dirty="0">
+                        <a:latin typeface="Calibri" charset="0"/>
+                        <a:ea typeface="Calibri" charset="0"/>
+                        <a:cs typeface="Calibri" charset="0"/>
+                      </a:endParaRPr>
+                    </a:p>
+                  </a:txBody>
+                  <a:tcPr marL="50800" marR="50800" marT="50800" marB="50800" anchor="ctr">
+                    <a:lnL w="6350" cap="flat" cmpd="sng" algn="ctr">
+                      <a:solidFill>
+                        <a:srgbClr val="CCCCCC"/>
+                      </a:solidFill>
+                      <a:prstDash val="solid"/>
+                      <a:round/>
+                      <a:headEnd type="none" w="med" len="med"/>
+                      <a:tailEnd type="none" w="med" len="med"/>
+                    </a:lnL>
+                    <a:lnR w="6350" cap="flat" cmpd="sng" algn="ctr">
+                      <a:solidFill>
+                        <a:srgbClr val="CCCCCC"/>
+                      </a:solidFill>
+                      <a:prstDash val="solid"/>
+                      <a:round/>
+                      <a:headEnd type="none" w="med" len="med"/>
+                      <a:tailEnd type="none" w="med" len="med"/>
+                    </a:lnR>
+                    <a:lnT w="6350" cap="flat" cmpd="sng" algn="ctr">
+                      <a:solidFill>
+                        <a:srgbClr val="CCCCCC"/>
+                      </a:solidFill>
+                      <a:prstDash val="solid"/>
+                      <a:round/>
+                      <a:headEnd type="none" w="med" len="med"/>
+                      <a:tailEnd type="none" w="med" len="med"/>
+                    </a:lnT>
+                    <a:lnB w="6350" cap="flat" cmpd="sng" algn="ctr">
+                      <a:solidFill>
+                        <a:srgbClr val="CCCCCC"/>
+                      </a:solidFill>
+                      <a:prstDash val="solid"/>
+                      <a:round/>
+                      <a:headEnd type="none" w="med" len="med"/>
+                      <a:tailEnd type="none" w="med" len="med"/>
+                    </a:lnB>
+                  </a:tcPr>
+                </a:tc>
+              </a:tr>
+              <a:tr h="0">
+                <a:tc>
+                  <a:txBody>
+                    <a:bodyPr/>
+                    <a:lstStyle/>
+                    <a:p>
+                      <a:pPr algn="l" indent="0" marL="0">
+                        <a:buNone/>
+                      </a:pPr>
+                      <a:r>
+                        <a:rPr lang="en-US" sz="1000" dirty="0">
+                          <a:solidFill>
+                            <a:srgbClr val="000000"/>
+                          </a:solidFill>
+                          <a:latin typeface="Calibri" pitchFamily="34" charset="0"/>
+                          <a:ea typeface="Calibri" pitchFamily="34" charset="-122"/>
+                          <a:cs typeface="Calibri" pitchFamily="34" charset="-120"/>
+                        </a:rPr>
+                        <a:t>Total</a:t>
+                      </a:r>
+                      <a:endParaRPr lang="en-US" sz="1000" dirty="0">
+                        <a:latin typeface="Calibri" charset="0"/>
+                        <a:ea typeface="Calibri" charset="0"/>
+                        <a:cs typeface="Calibri" charset="0"/>
+                      </a:endParaRPr>
+                    </a:p>
+                  </a:txBody>
+                  <a:tcPr marL="50800" marR="50800" marT="50800" marB="50800" anchor="ctr">
+                    <a:lnL w="6350" cap="flat" cmpd="sng" algn="ctr">
+                      <a:solidFill>
+                        <a:srgbClr val="CCCCCC"/>
+                      </a:solidFill>
+                      <a:prstDash val="solid"/>
+                      <a:round/>
+                      <a:headEnd type="none" w="med" len="med"/>
+                      <a:tailEnd type="none" w="med" len="med"/>
+                    </a:lnL>
+                    <a:lnR w="6350" cap="flat" cmpd="sng" algn="ctr">
+                      <a:solidFill>
+                        <a:srgbClr val="CCCCCC"/>
+                      </a:solidFill>
+                      <a:prstDash val="solid"/>
+                      <a:round/>
+                      <a:headEnd type="none" w="med" len="med"/>
+                      <a:tailEnd type="none" w="med" len="med"/>
+                    </a:lnR>
+                    <a:lnT w="6350" cap="flat" cmpd="sng" algn="ctr">
+                      <a:solidFill>
+                        <a:srgbClr val="CCCCCC"/>
+                      </a:solidFill>
+                      <a:prstDash val="solid"/>
+                      <a:round/>
+                      <a:headEnd type="none" w="med" len="med"/>
+                      <a:tailEnd type="none" w="med" len="med"/>
+                    </a:lnT>
+                    <a:lnB w="6350" cap="flat" cmpd="sng" algn="ctr">
+                      <a:solidFill>
+                        <a:srgbClr val="CCCCCC"/>
+                      </a:solidFill>
+                      <a:prstDash val="solid"/>
+                      <a:round/>
+                      <a:headEnd type="none" w="med" len="med"/>
+                      <a:tailEnd type="none" w="med" len="med"/>
+                    </a:lnB>
+                  </a:tcPr>
+                </a:tc>
+                <a:tc>
+                  <a:txBody>
+                    <a:bodyPr/>
+                    <a:lstStyle/>
+                    <a:p>
+                      <a:pPr algn="l" indent="0" marL="0">
+                        <a:buNone/>
+                      </a:pPr>
+                      <a:r>
+                        <a:rPr lang="en-US" sz="1000" dirty="0">
+                          <a:solidFill>
+                            <a:srgbClr val="000000"/>
+                          </a:solidFill>
+                          <a:latin typeface="Calibri" pitchFamily="34" charset="0"/>
+                          <a:ea typeface="Calibri" pitchFamily="34" charset="-122"/>
+                          <a:cs typeface="Calibri" pitchFamily="34" charset="-120"/>
+                        </a:rPr>
+                        <a:t>165</a:t>
                       </a:r>
                       <a:endParaRPr lang="en-US" sz="1000" dirty="0">
                         <a:latin typeface="Calibri" charset="0"/>
@@ -7172,7 +7369,7 @@
                 <a:ea typeface="Calibri" pitchFamily="34" charset="-122"/>
                 <a:cs typeface="Calibri" pitchFamily="34" charset="-120"/>
               </a:rPr>
-              <a:t>Total: 157 horas hombre · 5,500 USD</a:t>
+              <a:t>Total: 165 horas hombre · 5,500 USD</a:t>
             </a:r>
             <a:endParaRPr lang="en-US" sz="1200" dirty="0"/>
           </a:p>

</xml_diff>

<commit_message>
v2.43: Flujo desde tesorería, Matriz EF con estructura, Credicoop/s-f y sin caución.
Co-authored-by: Cursor <cursoragent@cursor.com>
</commit_message>
<xml_diff>
--- a/Propuesta_Dashboard_Flujo_Caja.pptx
+++ b/Propuesta_Dashboard_Flujo_Caja.pptx
@@ -1971,7 +1971,7 @@
                 <a:ea typeface="Calibri" pitchFamily="34" charset="-122"/>
                 <a:cs typeface="Calibri" pitchFamily="34" charset="-120"/>
               </a:rPr>
-              <a:t>▸ Proyectar los próximos meses y el interés por caución sobre el sobrante</a:t>
+              <a:t>▸ Proyectar los próximos meses a partir de la historia de ingresos y egresos</a:t>
             </a:r>
             <a:endParaRPr lang="en-US" sz="1200" dirty="0"/>
           </a:p>
@@ -2657,7 +2657,7 @@
                 <a:ea typeface="Calibri" pitchFamily="34" charset="-122"/>
                 <a:cs typeface="Calibri" pitchFamily="34" charset="-120"/>
               </a:rPr>
-              <a:t>Columna Int. por caución en flujo por mes: cálculo de interés mensual por reinversión del sobrante a un día co…</a:t>
+              <a:t>Trabajo histórico ya entregado: columna Caución, serie de tasas y modal de marcha. Retirado de la app; las hor…</a:t>
             </a:r>
             <a:endParaRPr lang="en-US" sz="900" dirty="0"/>
           </a:p>
@@ -3224,7 +3224,7 @@
                 <a:ea typeface="Calibri" pitchFamily="34" charset="-122"/>
                 <a:cs typeface="Calibri" pitchFamily="34" charset="-120"/>
               </a:rPr>
-              <a:t>▸ Flujo por mes con ingresos, egresos, G/P, ratios y columna de interés por caución</a:t>
+              <a:t>▸ Flujo por mes con ingresos, egresos, G/P y ratios (alimentado por tesorería)</a:t>
             </a:r>
             <a:endParaRPr lang="en-US" sz="1100" dirty="0"/>
           </a:p>
@@ -3497,7 +3497,7 @@
                 <a:ea typeface="Calibri" pitchFamily="34" charset="-122"/>
                 <a:cs typeface="Calibri" pitchFamily="34" charset="-120"/>
               </a:rPr>
-              <a:t>▸ Configuración por usuario (proyección, caución, alertas) guardada en la nube</a:t>
+              <a:t>▸ Configuración por usuario (proyección y alertas) guardada en la nube</a:t>
             </a:r>
             <a:endParaRPr lang="en-US" sz="1100" dirty="0"/>
           </a:p>
@@ -7153,7 +7153,7 @@
                           <a:ea typeface="Calibri" pitchFamily="34" charset="-122"/>
                           <a:cs typeface="Calibri" pitchFamily="34" charset="-120"/>
                         </a:rPr>
-                        <a:t>Total</a:t>
+                        <a:t>Matriz EF y Flujo desde tesorería</a:t>
                       </a:r>
                       <a:endParaRPr lang="en-US" sz="1000" dirty="0">
                         <a:latin typeface="Calibri" charset="0"/>
@@ -7218,7 +7218,204 @@
                           <a:ea typeface="Calibri" pitchFamily="34" charset="-122"/>
                           <a:cs typeface="Calibri" pitchFamily="34" charset="-120"/>
                         </a:rPr>
-                        <a:t>165</a:t>
+                        <a:t>24</a:t>
+                      </a:r>
+                      <a:endParaRPr lang="en-US" sz="1000" dirty="0">
+                        <a:latin typeface="Calibri" charset="0"/>
+                        <a:ea typeface="Calibri" charset="0"/>
+                        <a:cs typeface="Calibri" charset="0"/>
+                      </a:endParaRPr>
+                    </a:p>
+                  </a:txBody>
+                  <a:tcPr marL="50800" marR="50800" marT="50800" marB="50800" anchor="ctr">
+                    <a:lnL w="6350" cap="flat" cmpd="sng" algn="ctr">
+                      <a:solidFill>
+                        <a:srgbClr val="CCCCCC"/>
+                      </a:solidFill>
+                      <a:prstDash val="solid"/>
+                      <a:round/>
+                      <a:headEnd type="none" w="med" len="med"/>
+                      <a:tailEnd type="none" w="med" len="med"/>
+                    </a:lnL>
+                    <a:lnR w="6350" cap="flat" cmpd="sng" algn="ctr">
+                      <a:solidFill>
+                        <a:srgbClr val="CCCCCC"/>
+                      </a:solidFill>
+                      <a:prstDash val="solid"/>
+                      <a:round/>
+                      <a:headEnd type="none" w="med" len="med"/>
+                      <a:tailEnd type="none" w="med" len="med"/>
+                    </a:lnR>
+                    <a:lnT w="6350" cap="flat" cmpd="sng" algn="ctr">
+                      <a:solidFill>
+                        <a:srgbClr val="CCCCCC"/>
+                      </a:solidFill>
+                      <a:prstDash val="solid"/>
+                      <a:round/>
+                      <a:headEnd type="none" w="med" len="med"/>
+                      <a:tailEnd type="none" w="med" len="med"/>
+                    </a:lnT>
+                    <a:lnB w="6350" cap="flat" cmpd="sng" algn="ctr">
+                      <a:solidFill>
+                        <a:srgbClr val="CCCCCC"/>
+                      </a:solidFill>
+                      <a:prstDash val="solid"/>
+                      <a:round/>
+                      <a:headEnd type="none" w="med" len="med"/>
+                      <a:tailEnd type="none" w="med" len="med"/>
+                    </a:lnB>
+                  </a:tcPr>
+                </a:tc>
+                <a:tc>
+                  <a:txBody>
+                    <a:bodyPr/>
+                    <a:lstStyle/>
+                    <a:p>
+                      <a:pPr algn="l" indent="0" marL="0">
+                        <a:buNone/>
+                      </a:pPr>
+                      <a:r>
+                        <a:rPr lang="en-US" sz="1000" dirty="0">
+                          <a:solidFill>
+                            <a:srgbClr val="000000"/>
+                          </a:solidFill>
+                          <a:latin typeface="Calibri" pitchFamily="34" charset="0"/>
+                          <a:ea typeface="Calibri" pitchFamily="34" charset="-122"/>
+                          <a:cs typeface="Calibri" pitchFamily="34" charset="-120"/>
+                        </a:rPr>
+                        <a:t>0</a:t>
+                      </a:r>
+                      <a:endParaRPr lang="en-US" sz="1000" dirty="0">
+                        <a:latin typeface="Calibri" charset="0"/>
+                        <a:ea typeface="Calibri" charset="0"/>
+                        <a:cs typeface="Calibri" charset="0"/>
+                      </a:endParaRPr>
+                    </a:p>
+                  </a:txBody>
+                  <a:tcPr marL="50800" marR="50800" marT="50800" marB="50800" anchor="ctr">
+                    <a:lnL w="6350" cap="flat" cmpd="sng" algn="ctr">
+                      <a:solidFill>
+                        <a:srgbClr val="CCCCCC"/>
+                      </a:solidFill>
+                      <a:prstDash val="solid"/>
+                      <a:round/>
+                      <a:headEnd type="none" w="med" len="med"/>
+                      <a:tailEnd type="none" w="med" len="med"/>
+                    </a:lnL>
+                    <a:lnR w="6350" cap="flat" cmpd="sng" algn="ctr">
+                      <a:solidFill>
+                        <a:srgbClr val="CCCCCC"/>
+                      </a:solidFill>
+                      <a:prstDash val="solid"/>
+                      <a:round/>
+                      <a:headEnd type="none" w="med" len="med"/>
+                      <a:tailEnd type="none" w="med" len="med"/>
+                    </a:lnR>
+                    <a:lnT w="6350" cap="flat" cmpd="sng" algn="ctr">
+                      <a:solidFill>
+                        <a:srgbClr val="CCCCCC"/>
+                      </a:solidFill>
+                      <a:prstDash val="solid"/>
+                      <a:round/>
+                      <a:headEnd type="none" w="med" len="med"/>
+                      <a:tailEnd type="none" w="med" len="med"/>
+                    </a:lnT>
+                    <a:lnB w="6350" cap="flat" cmpd="sng" algn="ctr">
+                      <a:solidFill>
+                        <a:srgbClr val="CCCCCC"/>
+                      </a:solidFill>
+                      <a:prstDash val="solid"/>
+                      <a:round/>
+                      <a:headEnd type="none" w="med" len="med"/>
+                      <a:tailEnd type="none" w="med" len="med"/>
+                    </a:lnB>
+                  </a:tcPr>
+                </a:tc>
+              </a:tr>
+              <a:tr h="0">
+                <a:tc>
+                  <a:txBody>
+                    <a:bodyPr/>
+                    <a:lstStyle/>
+                    <a:p>
+                      <a:pPr algn="l" indent="0" marL="0">
+                        <a:buNone/>
+                      </a:pPr>
+                      <a:r>
+                        <a:rPr lang="en-US" sz="1000" dirty="0">
+                          <a:solidFill>
+                            <a:srgbClr val="000000"/>
+                          </a:solidFill>
+                          <a:latin typeface="Calibri" pitchFamily="34" charset="0"/>
+                          <a:ea typeface="Calibri" pitchFamily="34" charset="-122"/>
+                          <a:cs typeface="Calibri" pitchFamily="34" charset="-120"/>
+                        </a:rPr>
+                        <a:t>Total</a:t>
+                      </a:r>
+                      <a:endParaRPr lang="en-US" sz="1000" dirty="0">
+                        <a:latin typeface="Calibri" charset="0"/>
+                        <a:ea typeface="Calibri" charset="0"/>
+                        <a:cs typeface="Calibri" charset="0"/>
+                      </a:endParaRPr>
+                    </a:p>
+                  </a:txBody>
+                  <a:tcPr marL="50800" marR="50800" marT="50800" marB="50800" anchor="ctr">
+                    <a:lnL w="6350" cap="flat" cmpd="sng" algn="ctr">
+                      <a:solidFill>
+                        <a:srgbClr val="CCCCCC"/>
+                      </a:solidFill>
+                      <a:prstDash val="solid"/>
+                      <a:round/>
+                      <a:headEnd type="none" w="med" len="med"/>
+                      <a:tailEnd type="none" w="med" len="med"/>
+                    </a:lnL>
+                    <a:lnR w="6350" cap="flat" cmpd="sng" algn="ctr">
+                      <a:solidFill>
+                        <a:srgbClr val="CCCCCC"/>
+                      </a:solidFill>
+                      <a:prstDash val="solid"/>
+                      <a:round/>
+                      <a:headEnd type="none" w="med" len="med"/>
+                      <a:tailEnd type="none" w="med" len="med"/>
+                    </a:lnR>
+                    <a:lnT w="6350" cap="flat" cmpd="sng" algn="ctr">
+                      <a:solidFill>
+                        <a:srgbClr val="CCCCCC"/>
+                      </a:solidFill>
+                      <a:prstDash val="solid"/>
+                      <a:round/>
+                      <a:headEnd type="none" w="med" len="med"/>
+                      <a:tailEnd type="none" w="med" len="med"/>
+                    </a:lnT>
+                    <a:lnB w="6350" cap="flat" cmpd="sng" algn="ctr">
+                      <a:solidFill>
+                        <a:srgbClr val="CCCCCC"/>
+                      </a:solidFill>
+                      <a:prstDash val="solid"/>
+                      <a:round/>
+                      <a:headEnd type="none" w="med" len="med"/>
+                      <a:tailEnd type="none" w="med" len="med"/>
+                    </a:lnB>
+                  </a:tcPr>
+                </a:tc>
+                <a:tc>
+                  <a:txBody>
+                    <a:bodyPr/>
+                    <a:lstStyle/>
+                    <a:p>
+                      <a:pPr algn="l" indent="0" marL="0">
+                        <a:buNone/>
+                      </a:pPr>
+                      <a:r>
+                        <a:rPr lang="en-US" sz="1000" dirty="0">
+                          <a:solidFill>
+                            <a:srgbClr val="000000"/>
+                          </a:solidFill>
+                          <a:latin typeface="Calibri" pitchFamily="34" charset="0"/>
+                          <a:ea typeface="Calibri" pitchFamily="34" charset="-122"/>
+                          <a:cs typeface="Calibri" pitchFamily="34" charset="-120"/>
+                        </a:rPr>
+                        <a:t>189</a:t>
                       </a:r>
                       <a:endParaRPr lang="en-US" sz="1000" dirty="0">
                         <a:latin typeface="Calibri" charset="0"/>
@@ -7369,7 +7566,7 @@
                 <a:ea typeface="Calibri" pitchFamily="34" charset="-122"/>
                 <a:cs typeface="Calibri" pitchFamily="34" charset="-120"/>
               </a:rPr>
-              <a:t>Total: 165 horas hombre · 5,500 USD</a:t>
+              <a:t>Total: 189 horas hombre · 5,500 USD</a:t>
             </a:r>
             <a:endParaRPr lang="en-US" sz="1200" dirty="0"/>
           </a:p>

</xml_diff>

<commit_message>
v2.48: columna Usuario en tablas y aviso de nueva versión al entrar.
Co-authored-by: Cursor <cursoragent@cursor.com>
</commit_message>
<xml_diff>
--- a/Propuesta_Dashboard_Flujo_Caja.pptx
+++ b/Propuesta_Dashboard_Flujo_Caja.pptx
@@ -7350,7 +7350,7 @@
                           <a:ea typeface="Calibri" pitchFamily="34" charset="-122"/>
                           <a:cs typeface="Calibri" pitchFamily="34" charset="-120"/>
                         </a:rPr>
-                        <a:t>Total</a:t>
+                        <a:t>Aviso de nueva versión</a:t>
                       </a:r>
                       <a:endParaRPr lang="en-US" sz="1000" dirty="0">
                         <a:latin typeface="Calibri" charset="0"/>
@@ -7415,7 +7415,204 @@
                           <a:ea typeface="Calibri" pitchFamily="34" charset="-122"/>
                           <a:cs typeface="Calibri" pitchFamily="34" charset="-120"/>
                         </a:rPr>
-                        <a:t>189</a:t>
+                        <a:t>2</a:t>
+                      </a:r>
+                      <a:endParaRPr lang="en-US" sz="1000" dirty="0">
+                        <a:latin typeface="Calibri" charset="0"/>
+                        <a:ea typeface="Calibri" charset="0"/>
+                        <a:cs typeface="Calibri" charset="0"/>
+                      </a:endParaRPr>
+                    </a:p>
+                  </a:txBody>
+                  <a:tcPr marL="50800" marR="50800" marT="50800" marB="50800" anchor="ctr">
+                    <a:lnL w="6350" cap="flat" cmpd="sng" algn="ctr">
+                      <a:solidFill>
+                        <a:srgbClr val="CCCCCC"/>
+                      </a:solidFill>
+                      <a:prstDash val="solid"/>
+                      <a:round/>
+                      <a:headEnd type="none" w="med" len="med"/>
+                      <a:tailEnd type="none" w="med" len="med"/>
+                    </a:lnL>
+                    <a:lnR w="6350" cap="flat" cmpd="sng" algn="ctr">
+                      <a:solidFill>
+                        <a:srgbClr val="CCCCCC"/>
+                      </a:solidFill>
+                      <a:prstDash val="solid"/>
+                      <a:round/>
+                      <a:headEnd type="none" w="med" len="med"/>
+                      <a:tailEnd type="none" w="med" len="med"/>
+                    </a:lnR>
+                    <a:lnT w="6350" cap="flat" cmpd="sng" algn="ctr">
+                      <a:solidFill>
+                        <a:srgbClr val="CCCCCC"/>
+                      </a:solidFill>
+                      <a:prstDash val="solid"/>
+                      <a:round/>
+                      <a:headEnd type="none" w="med" len="med"/>
+                      <a:tailEnd type="none" w="med" len="med"/>
+                    </a:lnT>
+                    <a:lnB w="6350" cap="flat" cmpd="sng" algn="ctr">
+                      <a:solidFill>
+                        <a:srgbClr val="CCCCCC"/>
+                      </a:solidFill>
+                      <a:prstDash val="solid"/>
+                      <a:round/>
+                      <a:headEnd type="none" w="med" len="med"/>
+                      <a:tailEnd type="none" w="med" len="med"/>
+                    </a:lnB>
+                  </a:tcPr>
+                </a:tc>
+                <a:tc>
+                  <a:txBody>
+                    <a:bodyPr/>
+                    <a:lstStyle/>
+                    <a:p>
+                      <a:pPr algn="l" indent="0" marL="0">
+                        <a:buNone/>
+                      </a:pPr>
+                      <a:r>
+                        <a:rPr lang="en-US" sz="1000" dirty="0">
+                          <a:solidFill>
+                            <a:srgbClr val="000000"/>
+                          </a:solidFill>
+                          <a:latin typeface="Calibri" pitchFamily="34" charset="0"/>
+                          <a:ea typeface="Calibri" pitchFamily="34" charset="-122"/>
+                          <a:cs typeface="Calibri" pitchFamily="34" charset="-120"/>
+                        </a:rPr>
+                        <a:t>0</a:t>
+                      </a:r>
+                      <a:endParaRPr lang="en-US" sz="1000" dirty="0">
+                        <a:latin typeface="Calibri" charset="0"/>
+                        <a:ea typeface="Calibri" charset="0"/>
+                        <a:cs typeface="Calibri" charset="0"/>
+                      </a:endParaRPr>
+                    </a:p>
+                  </a:txBody>
+                  <a:tcPr marL="50800" marR="50800" marT="50800" marB="50800" anchor="ctr">
+                    <a:lnL w="6350" cap="flat" cmpd="sng" algn="ctr">
+                      <a:solidFill>
+                        <a:srgbClr val="CCCCCC"/>
+                      </a:solidFill>
+                      <a:prstDash val="solid"/>
+                      <a:round/>
+                      <a:headEnd type="none" w="med" len="med"/>
+                      <a:tailEnd type="none" w="med" len="med"/>
+                    </a:lnL>
+                    <a:lnR w="6350" cap="flat" cmpd="sng" algn="ctr">
+                      <a:solidFill>
+                        <a:srgbClr val="CCCCCC"/>
+                      </a:solidFill>
+                      <a:prstDash val="solid"/>
+                      <a:round/>
+                      <a:headEnd type="none" w="med" len="med"/>
+                      <a:tailEnd type="none" w="med" len="med"/>
+                    </a:lnR>
+                    <a:lnT w="6350" cap="flat" cmpd="sng" algn="ctr">
+                      <a:solidFill>
+                        <a:srgbClr val="CCCCCC"/>
+                      </a:solidFill>
+                      <a:prstDash val="solid"/>
+                      <a:round/>
+                      <a:headEnd type="none" w="med" len="med"/>
+                      <a:tailEnd type="none" w="med" len="med"/>
+                    </a:lnT>
+                    <a:lnB w="6350" cap="flat" cmpd="sng" algn="ctr">
+                      <a:solidFill>
+                        <a:srgbClr val="CCCCCC"/>
+                      </a:solidFill>
+                      <a:prstDash val="solid"/>
+                      <a:round/>
+                      <a:headEnd type="none" w="med" len="med"/>
+                      <a:tailEnd type="none" w="med" len="med"/>
+                    </a:lnB>
+                  </a:tcPr>
+                </a:tc>
+              </a:tr>
+              <a:tr h="0">
+                <a:tc>
+                  <a:txBody>
+                    <a:bodyPr/>
+                    <a:lstStyle/>
+                    <a:p>
+                      <a:pPr algn="l" indent="0" marL="0">
+                        <a:buNone/>
+                      </a:pPr>
+                      <a:r>
+                        <a:rPr lang="en-US" sz="1000" dirty="0">
+                          <a:solidFill>
+                            <a:srgbClr val="000000"/>
+                          </a:solidFill>
+                          <a:latin typeface="Calibri" pitchFamily="34" charset="0"/>
+                          <a:ea typeface="Calibri" pitchFamily="34" charset="-122"/>
+                          <a:cs typeface="Calibri" pitchFamily="34" charset="-120"/>
+                        </a:rPr>
+                        <a:t>Total</a:t>
+                      </a:r>
+                      <a:endParaRPr lang="en-US" sz="1000" dirty="0">
+                        <a:latin typeface="Calibri" charset="0"/>
+                        <a:ea typeface="Calibri" charset="0"/>
+                        <a:cs typeface="Calibri" charset="0"/>
+                      </a:endParaRPr>
+                    </a:p>
+                  </a:txBody>
+                  <a:tcPr marL="50800" marR="50800" marT="50800" marB="50800" anchor="ctr">
+                    <a:lnL w="6350" cap="flat" cmpd="sng" algn="ctr">
+                      <a:solidFill>
+                        <a:srgbClr val="CCCCCC"/>
+                      </a:solidFill>
+                      <a:prstDash val="solid"/>
+                      <a:round/>
+                      <a:headEnd type="none" w="med" len="med"/>
+                      <a:tailEnd type="none" w="med" len="med"/>
+                    </a:lnL>
+                    <a:lnR w="6350" cap="flat" cmpd="sng" algn="ctr">
+                      <a:solidFill>
+                        <a:srgbClr val="CCCCCC"/>
+                      </a:solidFill>
+                      <a:prstDash val="solid"/>
+                      <a:round/>
+                      <a:headEnd type="none" w="med" len="med"/>
+                      <a:tailEnd type="none" w="med" len="med"/>
+                    </a:lnR>
+                    <a:lnT w="6350" cap="flat" cmpd="sng" algn="ctr">
+                      <a:solidFill>
+                        <a:srgbClr val="CCCCCC"/>
+                      </a:solidFill>
+                      <a:prstDash val="solid"/>
+                      <a:round/>
+                      <a:headEnd type="none" w="med" len="med"/>
+                      <a:tailEnd type="none" w="med" len="med"/>
+                    </a:lnT>
+                    <a:lnB w="6350" cap="flat" cmpd="sng" algn="ctr">
+                      <a:solidFill>
+                        <a:srgbClr val="CCCCCC"/>
+                      </a:solidFill>
+                      <a:prstDash val="solid"/>
+                      <a:round/>
+                      <a:headEnd type="none" w="med" len="med"/>
+                      <a:tailEnd type="none" w="med" len="med"/>
+                    </a:lnB>
+                  </a:tcPr>
+                </a:tc>
+                <a:tc>
+                  <a:txBody>
+                    <a:bodyPr/>
+                    <a:lstStyle/>
+                    <a:p>
+                      <a:pPr algn="l" indent="0" marL="0">
+                        <a:buNone/>
+                      </a:pPr>
+                      <a:r>
+                        <a:rPr lang="en-US" sz="1000" dirty="0">
+                          <a:solidFill>
+                            <a:srgbClr val="000000"/>
+                          </a:solidFill>
+                          <a:latin typeface="Calibri" pitchFamily="34" charset="0"/>
+                          <a:ea typeface="Calibri" pitchFamily="34" charset="-122"/>
+                          <a:cs typeface="Calibri" pitchFamily="34" charset="-120"/>
+                        </a:rPr>
+                        <a:t>191</a:t>
                       </a:r>
                       <a:endParaRPr lang="en-US" sz="1000" dirty="0">
                         <a:latin typeface="Calibri" charset="0"/>
@@ -7566,7 +7763,7 @@
                 <a:ea typeface="Calibri" pitchFamily="34" charset="-122"/>
                 <a:cs typeface="Calibri" pitchFamily="34" charset="-120"/>
               </a:rPr>
-              <a:t>Total: 189 horas hombre · 5,500 USD</a:t>
+              <a:t>Total: 191 horas hombre · 5,500 USD</a:t>
             </a:r>
             <a:endParaRPr lang="en-US" sz="1200" dirty="0"/>
           </a:p>

</xml_diff>

<commit_message>
v2.100: hay un menú To-Do y en Seguridad se elige quién lo ve y quién crea tareas.
Co-authored-by: Cursor <cursoragent@cursor.com>
</commit_message>
<xml_diff>
--- a/Propuesta_Dashboard_Flujo_Caja.pptx
+++ b/Propuesta_Dashboard_Flujo_Caja.pptx
@@ -7547,7 +7547,7 @@
                           <a:ea typeface="Calibri" pitchFamily="34" charset="-122"/>
                           <a:cs typeface="Calibri" pitchFamily="34" charset="-120"/>
                         </a:rPr>
-                        <a:t>Total</a:t>
+                        <a:t>To-Do</a:t>
                       </a:r>
                       <a:endParaRPr lang="en-US" sz="1000" dirty="0">
                         <a:latin typeface="Calibri" charset="0"/>
@@ -7612,7 +7612,204 @@
                           <a:ea typeface="Calibri" pitchFamily="34" charset="-122"/>
                           <a:cs typeface="Calibri" pitchFamily="34" charset="-120"/>
                         </a:rPr>
-                        <a:t>191</a:t>
+                        <a:t>16</a:t>
+                      </a:r>
+                      <a:endParaRPr lang="en-US" sz="1000" dirty="0">
+                        <a:latin typeface="Calibri" charset="0"/>
+                        <a:ea typeface="Calibri" charset="0"/>
+                        <a:cs typeface="Calibri" charset="0"/>
+                      </a:endParaRPr>
+                    </a:p>
+                  </a:txBody>
+                  <a:tcPr marL="50800" marR="50800" marT="50800" marB="50800" anchor="ctr">
+                    <a:lnL w="6350" cap="flat" cmpd="sng" algn="ctr">
+                      <a:solidFill>
+                        <a:srgbClr val="CCCCCC"/>
+                      </a:solidFill>
+                      <a:prstDash val="solid"/>
+                      <a:round/>
+                      <a:headEnd type="none" w="med" len="med"/>
+                      <a:tailEnd type="none" w="med" len="med"/>
+                    </a:lnL>
+                    <a:lnR w="6350" cap="flat" cmpd="sng" algn="ctr">
+                      <a:solidFill>
+                        <a:srgbClr val="CCCCCC"/>
+                      </a:solidFill>
+                      <a:prstDash val="solid"/>
+                      <a:round/>
+                      <a:headEnd type="none" w="med" len="med"/>
+                      <a:tailEnd type="none" w="med" len="med"/>
+                    </a:lnR>
+                    <a:lnT w="6350" cap="flat" cmpd="sng" algn="ctr">
+                      <a:solidFill>
+                        <a:srgbClr val="CCCCCC"/>
+                      </a:solidFill>
+                      <a:prstDash val="solid"/>
+                      <a:round/>
+                      <a:headEnd type="none" w="med" len="med"/>
+                      <a:tailEnd type="none" w="med" len="med"/>
+                    </a:lnT>
+                    <a:lnB w="6350" cap="flat" cmpd="sng" algn="ctr">
+                      <a:solidFill>
+                        <a:srgbClr val="CCCCCC"/>
+                      </a:solidFill>
+                      <a:prstDash val="solid"/>
+                      <a:round/>
+                      <a:headEnd type="none" w="med" len="med"/>
+                      <a:tailEnd type="none" w="med" len="med"/>
+                    </a:lnB>
+                  </a:tcPr>
+                </a:tc>
+                <a:tc>
+                  <a:txBody>
+                    <a:bodyPr/>
+                    <a:lstStyle/>
+                    <a:p>
+                      <a:pPr algn="l" indent="0" marL="0">
+                        <a:buNone/>
+                      </a:pPr>
+                      <a:r>
+                        <a:rPr lang="en-US" sz="1000" dirty="0">
+                          <a:solidFill>
+                            <a:srgbClr val="000000"/>
+                          </a:solidFill>
+                          <a:latin typeface="Calibri" pitchFamily="34" charset="0"/>
+                          <a:ea typeface="Calibri" pitchFamily="34" charset="-122"/>
+                          <a:cs typeface="Calibri" pitchFamily="34" charset="-120"/>
+                        </a:rPr>
+                        <a:t>0</a:t>
+                      </a:r>
+                      <a:endParaRPr lang="en-US" sz="1000" dirty="0">
+                        <a:latin typeface="Calibri" charset="0"/>
+                        <a:ea typeface="Calibri" charset="0"/>
+                        <a:cs typeface="Calibri" charset="0"/>
+                      </a:endParaRPr>
+                    </a:p>
+                  </a:txBody>
+                  <a:tcPr marL="50800" marR="50800" marT="50800" marB="50800" anchor="ctr">
+                    <a:lnL w="6350" cap="flat" cmpd="sng" algn="ctr">
+                      <a:solidFill>
+                        <a:srgbClr val="CCCCCC"/>
+                      </a:solidFill>
+                      <a:prstDash val="solid"/>
+                      <a:round/>
+                      <a:headEnd type="none" w="med" len="med"/>
+                      <a:tailEnd type="none" w="med" len="med"/>
+                    </a:lnL>
+                    <a:lnR w="6350" cap="flat" cmpd="sng" algn="ctr">
+                      <a:solidFill>
+                        <a:srgbClr val="CCCCCC"/>
+                      </a:solidFill>
+                      <a:prstDash val="solid"/>
+                      <a:round/>
+                      <a:headEnd type="none" w="med" len="med"/>
+                      <a:tailEnd type="none" w="med" len="med"/>
+                    </a:lnR>
+                    <a:lnT w="6350" cap="flat" cmpd="sng" algn="ctr">
+                      <a:solidFill>
+                        <a:srgbClr val="CCCCCC"/>
+                      </a:solidFill>
+                      <a:prstDash val="solid"/>
+                      <a:round/>
+                      <a:headEnd type="none" w="med" len="med"/>
+                      <a:tailEnd type="none" w="med" len="med"/>
+                    </a:lnT>
+                    <a:lnB w="6350" cap="flat" cmpd="sng" algn="ctr">
+                      <a:solidFill>
+                        <a:srgbClr val="CCCCCC"/>
+                      </a:solidFill>
+                      <a:prstDash val="solid"/>
+                      <a:round/>
+                      <a:headEnd type="none" w="med" len="med"/>
+                      <a:tailEnd type="none" w="med" len="med"/>
+                    </a:lnB>
+                  </a:tcPr>
+                </a:tc>
+              </a:tr>
+              <a:tr h="0">
+                <a:tc>
+                  <a:txBody>
+                    <a:bodyPr/>
+                    <a:lstStyle/>
+                    <a:p>
+                      <a:pPr algn="l" indent="0" marL="0">
+                        <a:buNone/>
+                      </a:pPr>
+                      <a:r>
+                        <a:rPr lang="en-US" sz="1000" dirty="0">
+                          <a:solidFill>
+                            <a:srgbClr val="000000"/>
+                          </a:solidFill>
+                          <a:latin typeface="Calibri" pitchFamily="34" charset="0"/>
+                          <a:ea typeface="Calibri" pitchFamily="34" charset="-122"/>
+                          <a:cs typeface="Calibri" pitchFamily="34" charset="-120"/>
+                        </a:rPr>
+                        <a:t>Total</a:t>
+                      </a:r>
+                      <a:endParaRPr lang="en-US" sz="1000" dirty="0">
+                        <a:latin typeface="Calibri" charset="0"/>
+                        <a:ea typeface="Calibri" charset="0"/>
+                        <a:cs typeface="Calibri" charset="0"/>
+                      </a:endParaRPr>
+                    </a:p>
+                  </a:txBody>
+                  <a:tcPr marL="50800" marR="50800" marT="50800" marB="50800" anchor="ctr">
+                    <a:lnL w="6350" cap="flat" cmpd="sng" algn="ctr">
+                      <a:solidFill>
+                        <a:srgbClr val="CCCCCC"/>
+                      </a:solidFill>
+                      <a:prstDash val="solid"/>
+                      <a:round/>
+                      <a:headEnd type="none" w="med" len="med"/>
+                      <a:tailEnd type="none" w="med" len="med"/>
+                    </a:lnL>
+                    <a:lnR w="6350" cap="flat" cmpd="sng" algn="ctr">
+                      <a:solidFill>
+                        <a:srgbClr val="CCCCCC"/>
+                      </a:solidFill>
+                      <a:prstDash val="solid"/>
+                      <a:round/>
+                      <a:headEnd type="none" w="med" len="med"/>
+                      <a:tailEnd type="none" w="med" len="med"/>
+                    </a:lnR>
+                    <a:lnT w="6350" cap="flat" cmpd="sng" algn="ctr">
+                      <a:solidFill>
+                        <a:srgbClr val="CCCCCC"/>
+                      </a:solidFill>
+                      <a:prstDash val="solid"/>
+                      <a:round/>
+                      <a:headEnd type="none" w="med" len="med"/>
+                      <a:tailEnd type="none" w="med" len="med"/>
+                    </a:lnT>
+                    <a:lnB w="6350" cap="flat" cmpd="sng" algn="ctr">
+                      <a:solidFill>
+                        <a:srgbClr val="CCCCCC"/>
+                      </a:solidFill>
+                      <a:prstDash val="solid"/>
+                      <a:round/>
+                      <a:headEnd type="none" w="med" len="med"/>
+                      <a:tailEnd type="none" w="med" len="med"/>
+                    </a:lnB>
+                  </a:tcPr>
+                </a:tc>
+                <a:tc>
+                  <a:txBody>
+                    <a:bodyPr/>
+                    <a:lstStyle/>
+                    <a:p>
+                      <a:pPr algn="l" indent="0" marL="0">
+                        <a:buNone/>
+                      </a:pPr>
+                      <a:r>
+                        <a:rPr lang="en-US" sz="1000" dirty="0">
+                          <a:solidFill>
+                            <a:srgbClr val="000000"/>
+                          </a:solidFill>
+                          <a:latin typeface="Calibri" pitchFamily="34" charset="0"/>
+                          <a:ea typeface="Calibri" pitchFamily="34" charset="-122"/>
+                          <a:cs typeface="Calibri" pitchFamily="34" charset="-120"/>
+                        </a:rPr>
+                        <a:t>207</a:t>
                       </a:r>
                       <a:endParaRPr lang="en-US" sz="1000" dirty="0">
                         <a:latin typeface="Calibri" charset="0"/>
@@ -7763,7 +7960,7 @@
                 <a:ea typeface="Calibri" pitchFamily="34" charset="-122"/>
                 <a:cs typeface="Calibri" pitchFamily="34" charset="-120"/>
               </a:rPr>
-              <a:t>Total: 191 horas hombre · 5,500 USD</a:t>
+              <a:t>Total: 207 horas hombre · 5,500 USD</a:t>
             </a:r>
             <a:endParaRPr lang="en-US" sz="1200" dirty="0"/>
           </a:p>

</xml_diff>

<commit_message>
v2.102: hay una agenda de pagos en Flujo de caja.
Co-authored-by: Cursor <cursoragent@cursor.com>
</commit_message>
<xml_diff>
--- a/Propuesta_Dashboard_Flujo_Caja.pptx
+++ b/Propuesta_Dashboard_Flujo_Caja.pptx
@@ -7744,7 +7744,7 @@
                           <a:ea typeface="Calibri" pitchFamily="34" charset="-122"/>
                           <a:cs typeface="Calibri" pitchFamily="34" charset="-120"/>
                         </a:rPr>
-                        <a:t>Total</a:t>
+                        <a:t>Agenda de pagos</a:t>
                       </a:r>
                       <a:endParaRPr lang="en-US" sz="1000" dirty="0">
                         <a:latin typeface="Calibri" charset="0"/>
@@ -7809,7 +7809,204 @@
                           <a:ea typeface="Calibri" pitchFamily="34" charset="-122"/>
                           <a:cs typeface="Calibri" pitchFamily="34" charset="-120"/>
                         </a:rPr>
-                        <a:t>207</a:t>
+                        <a:t>8</a:t>
+                      </a:r>
+                      <a:endParaRPr lang="en-US" sz="1000" dirty="0">
+                        <a:latin typeface="Calibri" charset="0"/>
+                        <a:ea typeface="Calibri" charset="0"/>
+                        <a:cs typeface="Calibri" charset="0"/>
+                      </a:endParaRPr>
+                    </a:p>
+                  </a:txBody>
+                  <a:tcPr marL="50800" marR="50800" marT="50800" marB="50800" anchor="ctr">
+                    <a:lnL w="6350" cap="flat" cmpd="sng" algn="ctr">
+                      <a:solidFill>
+                        <a:srgbClr val="CCCCCC"/>
+                      </a:solidFill>
+                      <a:prstDash val="solid"/>
+                      <a:round/>
+                      <a:headEnd type="none" w="med" len="med"/>
+                      <a:tailEnd type="none" w="med" len="med"/>
+                    </a:lnL>
+                    <a:lnR w="6350" cap="flat" cmpd="sng" algn="ctr">
+                      <a:solidFill>
+                        <a:srgbClr val="CCCCCC"/>
+                      </a:solidFill>
+                      <a:prstDash val="solid"/>
+                      <a:round/>
+                      <a:headEnd type="none" w="med" len="med"/>
+                      <a:tailEnd type="none" w="med" len="med"/>
+                    </a:lnR>
+                    <a:lnT w="6350" cap="flat" cmpd="sng" algn="ctr">
+                      <a:solidFill>
+                        <a:srgbClr val="CCCCCC"/>
+                      </a:solidFill>
+                      <a:prstDash val="solid"/>
+                      <a:round/>
+                      <a:headEnd type="none" w="med" len="med"/>
+                      <a:tailEnd type="none" w="med" len="med"/>
+                    </a:lnT>
+                    <a:lnB w="6350" cap="flat" cmpd="sng" algn="ctr">
+                      <a:solidFill>
+                        <a:srgbClr val="CCCCCC"/>
+                      </a:solidFill>
+                      <a:prstDash val="solid"/>
+                      <a:round/>
+                      <a:headEnd type="none" w="med" len="med"/>
+                      <a:tailEnd type="none" w="med" len="med"/>
+                    </a:lnB>
+                  </a:tcPr>
+                </a:tc>
+                <a:tc>
+                  <a:txBody>
+                    <a:bodyPr/>
+                    <a:lstStyle/>
+                    <a:p>
+                      <a:pPr algn="l" indent="0" marL="0">
+                        <a:buNone/>
+                      </a:pPr>
+                      <a:r>
+                        <a:rPr lang="en-US" sz="1000" dirty="0">
+                          <a:solidFill>
+                            <a:srgbClr val="000000"/>
+                          </a:solidFill>
+                          <a:latin typeface="Calibri" pitchFamily="34" charset="0"/>
+                          <a:ea typeface="Calibri" pitchFamily="34" charset="-122"/>
+                          <a:cs typeface="Calibri" pitchFamily="34" charset="-120"/>
+                        </a:rPr>
+                        <a:t>0</a:t>
+                      </a:r>
+                      <a:endParaRPr lang="en-US" sz="1000" dirty="0">
+                        <a:latin typeface="Calibri" charset="0"/>
+                        <a:ea typeface="Calibri" charset="0"/>
+                        <a:cs typeface="Calibri" charset="0"/>
+                      </a:endParaRPr>
+                    </a:p>
+                  </a:txBody>
+                  <a:tcPr marL="50800" marR="50800" marT="50800" marB="50800" anchor="ctr">
+                    <a:lnL w="6350" cap="flat" cmpd="sng" algn="ctr">
+                      <a:solidFill>
+                        <a:srgbClr val="CCCCCC"/>
+                      </a:solidFill>
+                      <a:prstDash val="solid"/>
+                      <a:round/>
+                      <a:headEnd type="none" w="med" len="med"/>
+                      <a:tailEnd type="none" w="med" len="med"/>
+                    </a:lnL>
+                    <a:lnR w="6350" cap="flat" cmpd="sng" algn="ctr">
+                      <a:solidFill>
+                        <a:srgbClr val="CCCCCC"/>
+                      </a:solidFill>
+                      <a:prstDash val="solid"/>
+                      <a:round/>
+                      <a:headEnd type="none" w="med" len="med"/>
+                      <a:tailEnd type="none" w="med" len="med"/>
+                    </a:lnR>
+                    <a:lnT w="6350" cap="flat" cmpd="sng" algn="ctr">
+                      <a:solidFill>
+                        <a:srgbClr val="CCCCCC"/>
+                      </a:solidFill>
+                      <a:prstDash val="solid"/>
+                      <a:round/>
+                      <a:headEnd type="none" w="med" len="med"/>
+                      <a:tailEnd type="none" w="med" len="med"/>
+                    </a:lnT>
+                    <a:lnB w="6350" cap="flat" cmpd="sng" algn="ctr">
+                      <a:solidFill>
+                        <a:srgbClr val="CCCCCC"/>
+                      </a:solidFill>
+                      <a:prstDash val="solid"/>
+                      <a:round/>
+                      <a:headEnd type="none" w="med" len="med"/>
+                      <a:tailEnd type="none" w="med" len="med"/>
+                    </a:lnB>
+                  </a:tcPr>
+                </a:tc>
+              </a:tr>
+              <a:tr h="0">
+                <a:tc>
+                  <a:txBody>
+                    <a:bodyPr/>
+                    <a:lstStyle/>
+                    <a:p>
+                      <a:pPr algn="l" indent="0" marL="0">
+                        <a:buNone/>
+                      </a:pPr>
+                      <a:r>
+                        <a:rPr lang="en-US" sz="1000" dirty="0">
+                          <a:solidFill>
+                            <a:srgbClr val="000000"/>
+                          </a:solidFill>
+                          <a:latin typeface="Calibri" pitchFamily="34" charset="0"/>
+                          <a:ea typeface="Calibri" pitchFamily="34" charset="-122"/>
+                          <a:cs typeface="Calibri" pitchFamily="34" charset="-120"/>
+                        </a:rPr>
+                        <a:t>Total</a:t>
+                      </a:r>
+                      <a:endParaRPr lang="en-US" sz="1000" dirty="0">
+                        <a:latin typeface="Calibri" charset="0"/>
+                        <a:ea typeface="Calibri" charset="0"/>
+                        <a:cs typeface="Calibri" charset="0"/>
+                      </a:endParaRPr>
+                    </a:p>
+                  </a:txBody>
+                  <a:tcPr marL="50800" marR="50800" marT="50800" marB="50800" anchor="ctr">
+                    <a:lnL w="6350" cap="flat" cmpd="sng" algn="ctr">
+                      <a:solidFill>
+                        <a:srgbClr val="CCCCCC"/>
+                      </a:solidFill>
+                      <a:prstDash val="solid"/>
+                      <a:round/>
+                      <a:headEnd type="none" w="med" len="med"/>
+                      <a:tailEnd type="none" w="med" len="med"/>
+                    </a:lnL>
+                    <a:lnR w="6350" cap="flat" cmpd="sng" algn="ctr">
+                      <a:solidFill>
+                        <a:srgbClr val="CCCCCC"/>
+                      </a:solidFill>
+                      <a:prstDash val="solid"/>
+                      <a:round/>
+                      <a:headEnd type="none" w="med" len="med"/>
+                      <a:tailEnd type="none" w="med" len="med"/>
+                    </a:lnR>
+                    <a:lnT w="6350" cap="flat" cmpd="sng" algn="ctr">
+                      <a:solidFill>
+                        <a:srgbClr val="CCCCCC"/>
+                      </a:solidFill>
+                      <a:prstDash val="solid"/>
+                      <a:round/>
+                      <a:headEnd type="none" w="med" len="med"/>
+                      <a:tailEnd type="none" w="med" len="med"/>
+                    </a:lnT>
+                    <a:lnB w="6350" cap="flat" cmpd="sng" algn="ctr">
+                      <a:solidFill>
+                        <a:srgbClr val="CCCCCC"/>
+                      </a:solidFill>
+                      <a:prstDash val="solid"/>
+                      <a:round/>
+                      <a:headEnd type="none" w="med" len="med"/>
+                      <a:tailEnd type="none" w="med" len="med"/>
+                    </a:lnB>
+                  </a:tcPr>
+                </a:tc>
+                <a:tc>
+                  <a:txBody>
+                    <a:bodyPr/>
+                    <a:lstStyle/>
+                    <a:p>
+                      <a:pPr algn="l" indent="0" marL="0">
+                        <a:buNone/>
+                      </a:pPr>
+                      <a:r>
+                        <a:rPr lang="en-US" sz="1000" dirty="0">
+                          <a:solidFill>
+                            <a:srgbClr val="000000"/>
+                          </a:solidFill>
+                          <a:latin typeface="Calibri" pitchFamily="34" charset="0"/>
+                          <a:ea typeface="Calibri" pitchFamily="34" charset="-122"/>
+                          <a:cs typeface="Calibri" pitchFamily="34" charset="-120"/>
+                        </a:rPr>
+                        <a:t>215</a:t>
                       </a:r>
                       <a:endParaRPr lang="en-US" sz="1000" dirty="0">
                         <a:latin typeface="Calibri" charset="0"/>
@@ -7960,7 +8157,7 @@
                 <a:ea typeface="Calibri" pitchFamily="34" charset="-122"/>
                 <a:cs typeface="Calibri" pitchFamily="34" charset="-120"/>
               </a:rPr>
-              <a:t>Total: 207 horas hombre · 5,500 USD</a:t>
+              <a:t>Total: 215 horas hombre · 5,500 USD</a:t>
             </a:r>
             <a:endParaRPr lang="en-US" sz="1200" dirty="0"/>
           </a:p>

</xml_diff>